<commit_message>
Rapport fini, faut faire la modification du registre de commande et a le mettre dans le rapport
</commit_message>
<xml_diff>
--- a/Rapport/Mise_en_forme_image.pptx
+++ b/Rapport/Mise_en_forme_image.pptx
@@ -7,6 +7,9 @@
   <p:sldIdLst>
     <p:sldId id="256" r:id="rId2"/>
     <p:sldId id="257" r:id="rId3"/>
+    <p:sldId id="258" r:id="rId4"/>
+    <p:sldId id="259" r:id="rId5"/>
+    <p:sldId id="260" r:id="rId6"/>
   </p:sldIdLst>
   <p:sldSz cx="12192000" cy="6858000"/>
   <p:notesSz cx="6858000" cy="9144000"/>
@@ -260,7 +263,7 @@
           <a:p>
             <a:fld id="{7FD1F7A4-0D68-4580-B80A-F5393A26529E}" type="datetimeFigureOut">
               <a:rPr lang="fr-FR" smtClean="0"/>
-              <a:t>12/06/2026</a:t>
+              <a:t>14/06/2026</a:t>
             </a:fld>
             <a:endParaRPr lang="fr-FR"/>
           </a:p>
@@ -458,7 +461,7 @@
           <a:p>
             <a:fld id="{7FD1F7A4-0D68-4580-B80A-F5393A26529E}" type="datetimeFigureOut">
               <a:rPr lang="fr-FR" smtClean="0"/>
-              <a:t>12/06/2026</a:t>
+              <a:t>14/06/2026</a:t>
             </a:fld>
             <a:endParaRPr lang="fr-FR"/>
           </a:p>
@@ -666,7 +669,7 @@
           <a:p>
             <a:fld id="{7FD1F7A4-0D68-4580-B80A-F5393A26529E}" type="datetimeFigureOut">
               <a:rPr lang="fr-FR" smtClean="0"/>
-              <a:t>12/06/2026</a:t>
+              <a:t>14/06/2026</a:t>
             </a:fld>
             <a:endParaRPr lang="fr-FR"/>
           </a:p>
@@ -864,7 +867,7 @@
           <a:p>
             <a:fld id="{7FD1F7A4-0D68-4580-B80A-F5393A26529E}" type="datetimeFigureOut">
               <a:rPr lang="fr-FR" smtClean="0"/>
-              <a:t>12/06/2026</a:t>
+              <a:t>14/06/2026</a:t>
             </a:fld>
             <a:endParaRPr lang="fr-FR"/>
           </a:p>
@@ -1139,7 +1142,7 @@
           <a:p>
             <a:fld id="{7FD1F7A4-0D68-4580-B80A-F5393A26529E}" type="datetimeFigureOut">
               <a:rPr lang="fr-FR" smtClean="0"/>
-              <a:t>12/06/2026</a:t>
+              <a:t>14/06/2026</a:t>
             </a:fld>
             <a:endParaRPr lang="fr-FR"/>
           </a:p>
@@ -1404,7 +1407,7 @@
           <a:p>
             <a:fld id="{7FD1F7A4-0D68-4580-B80A-F5393A26529E}" type="datetimeFigureOut">
               <a:rPr lang="fr-FR" smtClean="0"/>
-              <a:t>12/06/2026</a:t>
+              <a:t>14/06/2026</a:t>
             </a:fld>
             <a:endParaRPr lang="fr-FR"/>
           </a:p>
@@ -1816,7 +1819,7 @@
           <a:p>
             <a:fld id="{7FD1F7A4-0D68-4580-B80A-F5393A26529E}" type="datetimeFigureOut">
               <a:rPr lang="fr-FR" smtClean="0"/>
-              <a:t>12/06/2026</a:t>
+              <a:t>14/06/2026</a:t>
             </a:fld>
             <a:endParaRPr lang="fr-FR"/>
           </a:p>
@@ -1957,7 +1960,7 @@
           <a:p>
             <a:fld id="{7FD1F7A4-0D68-4580-B80A-F5393A26529E}" type="datetimeFigureOut">
               <a:rPr lang="fr-FR" smtClean="0"/>
-              <a:t>12/06/2026</a:t>
+              <a:t>14/06/2026</a:t>
             </a:fld>
             <a:endParaRPr lang="fr-FR"/>
           </a:p>
@@ -2070,7 +2073,7 @@
           <a:p>
             <a:fld id="{7FD1F7A4-0D68-4580-B80A-F5393A26529E}" type="datetimeFigureOut">
               <a:rPr lang="fr-FR" smtClean="0"/>
-              <a:t>12/06/2026</a:t>
+              <a:t>14/06/2026</a:t>
             </a:fld>
             <a:endParaRPr lang="fr-FR"/>
           </a:p>
@@ -2381,7 +2384,7 @@
           <a:p>
             <a:fld id="{7FD1F7A4-0D68-4580-B80A-F5393A26529E}" type="datetimeFigureOut">
               <a:rPr lang="fr-FR" smtClean="0"/>
-              <a:t>12/06/2026</a:t>
+              <a:t>14/06/2026</a:t>
             </a:fld>
             <a:endParaRPr lang="fr-FR"/>
           </a:p>
@@ -2669,7 +2672,7 @@
           <a:p>
             <a:fld id="{7FD1F7A4-0D68-4580-B80A-F5393A26529E}" type="datetimeFigureOut">
               <a:rPr lang="fr-FR" smtClean="0"/>
-              <a:t>12/06/2026</a:t>
+              <a:t>14/06/2026</a:t>
             </a:fld>
             <a:endParaRPr lang="fr-FR"/>
           </a:p>
@@ -2910,7 +2913,7 @@
           <a:p>
             <a:fld id="{7FD1F7A4-0D68-4580-B80A-F5393A26529E}" type="datetimeFigureOut">
               <a:rPr lang="fr-FR" smtClean="0"/>
-              <a:t>12/06/2026</a:t>
+              <a:t>14/06/2026</a:t>
             </a:fld>
             <a:endParaRPr lang="fr-FR"/>
           </a:p>
@@ -3713,6 +3716,695 @@
 </p:sld>
 </file>
 
+<file path=ppt/slides/slide3.xml><?xml version="1.0" encoding="utf-8"?>
+<p:sld xmlns:a="http://schemas.openxmlformats.org/drawingml/2006/main" xmlns:r="http://schemas.openxmlformats.org/officeDocument/2006/relationships" xmlns:p="http://schemas.openxmlformats.org/presentationml/2006/main">
+  <p:cSld>
+    <p:spTree>
+      <p:nvGrpSpPr>
+        <p:cNvPr id="1" name=""/>
+        <p:cNvGrpSpPr/>
+        <p:nvPr/>
+      </p:nvGrpSpPr>
+      <p:grpSpPr>
+        <a:xfrm>
+          <a:off x="0" y="0"/>
+          <a:ext cx="0" cy="0"/>
+          <a:chOff x="0" y="0"/>
+          <a:chExt cx="0" cy="0"/>
+        </a:xfrm>
+      </p:grpSpPr>
+      <p:pic>
+        <p:nvPicPr>
+          <p:cNvPr id="5" name="Image 4">
+            <a:extLst>
+              <a:ext uri="{FF2B5EF4-FFF2-40B4-BE49-F238E27FC236}">
+                <a16:creationId xmlns:a16="http://schemas.microsoft.com/office/drawing/2014/main" id="{FE792334-7E66-29A5-8B55-F99F5B44CE4D}"/>
+              </a:ext>
+            </a:extLst>
+          </p:cNvPr>
+          <p:cNvPicPr>
+            <a:picLocks noChangeAspect="1"/>
+          </p:cNvPicPr>
+          <p:nvPr/>
+        </p:nvPicPr>
+        <p:blipFill>
+          <a:blip r:embed="rId2"/>
+          <a:stretch>
+            <a:fillRect/>
+          </a:stretch>
+        </p:blipFill>
+        <p:spPr>
+          <a:xfrm>
+            <a:off x="1242179" y="1867259"/>
+            <a:ext cx="4248743" cy="266737"/>
+          </a:xfrm>
+          <a:prstGeom prst="rect">
+            <a:avLst/>
+          </a:prstGeom>
+        </p:spPr>
+      </p:pic>
+      <p:pic>
+        <p:nvPicPr>
+          <p:cNvPr id="9" name="Image 8">
+            <a:extLst>
+              <a:ext uri="{FF2B5EF4-FFF2-40B4-BE49-F238E27FC236}">
+                <a16:creationId xmlns:a16="http://schemas.microsoft.com/office/drawing/2014/main" id="{1A952014-C254-8B21-AB3D-210DBCC82FFB}"/>
+              </a:ext>
+            </a:extLst>
+          </p:cNvPr>
+          <p:cNvPicPr>
+            <a:picLocks noChangeAspect="1"/>
+          </p:cNvPicPr>
+          <p:nvPr/>
+        </p:nvPicPr>
+        <p:blipFill>
+          <a:blip r:embed="rId3"/>
+          <a:srcRect t="31063" b="13859"/>
+          <a:stretch/>
+        </p:blipFill>
+        <p:spPr>
+          <a:xfrm>
+            <a:off x="1095555" y="2626044"/>
+            <a:ext cx="4541993" cy="2674188"/>
+          </a:xfrm>
+          <a:prstGeom prst="roundRect">
+            <a:avLst/>
+          </a:prstGeom>
+        </p:spPr>
+      </p:pic>
+      <p:pic>
+        <p:nvPicPr>
+          <p:cNvPr id="11" name="Image 10">
+            <a:extLst>
+              <a:ext uri="{FF2B5EF4-FFF2-40B4-BE49-F238E27FC236}">
+                <a16:creationId xmlns:a16="http://schemas.microsoft.com/office/drawing/2014/main" id="{9FF933CA-2022-8DF0-3C95-F65443EF1A2E}"/>
+              </a:ext>
+            </a:extLst>
+          </p:cNvPr>
+          <p:cNvPicPr>
+            <a:picLocks noChangeAspect="1"/>
+          </p:cNvPicPr>
+          <p:nvPr/>
+        </p:nvPicPr>
+        <p:blipFill>
+          <a:blip r:embed="rId4"/>
+          <a:stretch>
+            <a:fillRect/>
+          </a:stretch>
+        </p:blipFill>
+        <p:spPr>
+          <a:xfrm>
+            <a:off x="5893514" y="2000627"/>
+            <a:ext cx="6039693" cy="2686425"/>
+          </a:xfrm>
+          <a:prstGeom prst="roundRect">
+            <a:avLst>
+              <a:gd name="adj" fmla="val 10887"/>
+            </a:avLst>
+          </a:prstGeom>
+        </p:spPr>
+      </p:pic>
+      <p:sp>
+        <p:nvSpPr>
+          <p:cNvPr id="12" name="ZoneTexte 11">
+            <a:extLst>
+              <a:ext uri="{FF2B5EF4-FFF2-40B4-BE49-F238E27FC236}">
+                <a16:creationId xmlns:a16="http://schemas.microsoft.com/office/drawing/2014/main" id="{5DDA3993-169D-6D58-F5BF-4494ACCB4828}"/>
+              </a:ext>
+            </a:extLst>
+          </p:cNvPr>
+          <p:cNvSpPr txBox="1"/>
+          <p:nvPr/>
+        </p:nvSpPr>
+        <p:spPr>
+          <a:xfrm>
+            <a:off x="6821454" y="4787660"/>
+            <a:ext cx="4183811" cy="369332"/>
+          </a:xfrm>
+          <a:prstGeom prst="rect">
+            <a:avLst/>
+          </a:prstGeom>
+          <a:noFill/>
+        </p:spPr>
+        <p:txBody>
+          <a:bodyPr wrap="square" rtlCol="0">
+            <a:spAutoFit/>
+          </a:bodyPr>
+          <a:lstStyle/>
+          <a:p>
+            <a:pPr algn="ctr"/>
+            <a:r>
+              <a:rPr lang="fr-FR" dirty="0"/>
+              <a:t>Donnée de la mémoire</a:t>
+            </a:r>
+          </a:p>
+        </p:txBody>
+      </p:sp>
+      <p:sp>
+        <p:nvSpPr>
+          <p:cNvPr id="13" name="ZoneTexte 12">
+            <a:extLst>
+              <a:ext uri="{FF2B5EF4-FFF2-40B4-BE49-F238E27FC236}">
+                <a16:creationId xmlns:a16="http://schemas.microsoft.com/office/drawing/2014/main" id="{29E05C90-80DD-9DEB-D1C3-81628387349B}"/>
+              </a:ext>
+            </a:extLst>
+          </p:cNvPr>
+          <p:cNvSpPr txBox="1"/>
+          <p:nvPr/>
+        </p:nvSpPr>
+        <p:spPr>
+          <a:xfrm>
+            <a:off x="1274644" y="5300232"/>
+            <a:ext cx="4183811" cy="369332"/>
+          </a:xfrm>
+          <a:prstGeom prst="rect">
+            <a:avLst/>
+          </a:prstGeom>
+          <a:noFill/>
+        </p:spPr>
+        <p:txBody>
+          <a:bodyPr wrap="square" rtlCol="0">
+            <a:spAutoFit/>
+          </a:bodyPr>
+          <a:lstStyle/>
+          <a:p>
+            <a:pPr algn="ctr"/>
+            <a:r>
+              <a:rPr lang="fr-FR" dirty="0"/>
+              <a:t>Résultat sur DE10-Lite</a:t>
+            </a:r>
+          </a:p>
+        </p:txBody>
+      </p:sp>
+      <p:sp>
+        <p:nvSpPr>
+          <p:cNvPr id="15" name="ZoneTexte 14">
+            <a:extLst>
+              <a:ext uri="{FF2B5EF4-FFF2-40B4-BE49-F238E27FC236}">
+                <a16:creationId xmlns:a16="http://schemas.microsoft.com/office/drawing/2014/main" id="{5BFD3DBB-0E77-1538-FF4C-6B91B398C7EB}"/>
+              </a:ext>
+            </a:extLst>
+          </p:cNvPr>
+          <p:cNvSpPr txBox="1"/>
+          <p:nvPr/>
+        </p:nvSpPr>
+        <p:spPr>
+          <a:xfrm>
+            <a:off x="1274643" y="2121961"/>
+            <a:ext cx="4183811" cy="369332"/>
+          </a:xfrm>
+          <a:prstGeom prst="rect">
+            <a:avLst/>
+          </a:prstGeom>
+          <a:noFill/>
+        </p:spPr>
+        <p:txBody>
+          <a:bodyPr wrap="square" rtlCol="0">
+            <a:spAutoFit/>
+          </a:bodyPr>
+          <a:lstStyle/>
+          <a:p>
+            <a:pPr algn="ctr"/>
+            <a:r>
+              <a:rPr lang="fr-FR" dirty="0"/>
+              <a:t>Résultat sur simulation</a:t>
+            </a:r>
+          </a:p>
+        </p:txBody>
+      </p:sp>
+    </p:spTree>
+    <p:extLst>
+      <p:ext uri="{BB962C8B-B14F-4D97-AF65-F5344CB8AC3E}">
+        <p14:creationId xmlns:p14="http://schemas.microsoft.com/office/powerpoint/2010/main" val="3916419417"/>
+      </p:ext>
+    </p:extLst>
+  </p:cSld>
+  <p:clrMapOvr>
+    <a:masterClrMapping/>
+  </p:clrMapOvr>
+</p:sld>
+</file>
+
+<file path=ppt/slides/slide4.xml><?xml version="1.0" encoding="utf-8"?>
+<p:sld xmlns:a="http://schemas.openxmlformats.org/drawingml/2006/main" xmlns:r="http://schemas.openxmlformats.org/officeDocument/2006/relationships" xmlns:p="http://schemas.openxmlformats.org/presentationml/2006/main">
+  <p:cSld>
+    <p:spTree>
+      <p:nvGrpSpPr>
+        <p:cNvPr id="1" name=""/>
+        <p:cNvGrpSpPr/>
+        <p:nvPr/>
+      </p:nvGrpSpPr>
+      <p:grpSpPr>
+        <a:xfrm>
+          <a:off x="0" y="0"/>
+          <a:ext cx="0" cy="0"/>
+          <a:chOff x="0" y="0"/>
+          <a:chExt cx="0" cy="0"/>
+        </a:xfrm>
+      </p:grpSpPr>
+      <p:sp>
+        <p:nvSpPr>
+          <p:cNvPr id="12" name="ZoneTexte 11">
+            <a:extLst>
+              <a:ext uri="{FF2B5EF4-FFF2-40B4-BE49-F238E27FC236}">
+                <a16:creationId xmlns:a16="http://schemas.microsoft.com/office/drawing/2014/main" id="{5DDA3993-169D-6D58-F5BF-4494ACCB4828}"/>
+              </a:ext>
+            </a:extLst>
+          </p:cNvPr>
+          <p:cNvSpPr txBox="1"/>
+          <p:nvPr/>
+        </p:nvSpPr>
+        <p:spPr>
+          <a:xfrm>
+            <a:off x="6821454" y="4787660"/>
+            <a:ext cx="4183811" cy="369332"/>
+          </a:xfrm>
+          <a:prstGeom prst="rect">
+            <a:avLst/>
+          </a:prstGeom>
+          <a:noFill/>
+        </p:spPr>
+        <p:txBody>
+          <a:bodyPr wrap="square" rtlCol="0">
+            <a:spAutoFit/>
+          </a:bodyPr>
+          <a:lstStyle/>
+          <a:p>
+            <a:pPr algn="ctr"/>
+            <a:r>
+              <a:rPr lang="fr-FR" dirty="0"/>
+              <a:t>Donnée de la mémoire</a:t>
+            </a:r>
+          </a:p>
+        </p:txBody>
+      </p:sp>
+      <p:sp>
+        <p:nvSpPr>
+          <p:cNvPr id="13" name="ZoneTexte 12">
+            <a:extLst>
+              <a:ext uri="{FF2B5EF4-FFF2-40B4-BE49-F238E27FC236}">
+                <a16:creationId xmlns:a16="http://schemas.microsoft.com/office/drawing/2014/main" id="{29E05C90-80DD-9DEB-D1C3-81628387349B}"/>
+              </a:ext>
+            </a:extLst>
+          </p:cNvPr>
+          <p:cNvSpPr txBox="1"/>
+          <p:nvPr/>
+        </p:nvSpPr>
+        <p:spPr>
+          <a:xfrm>
+            <a:off x="1274644" y="5300232"/>
+            <a:ext cx="4183811" cy="369332"/>
+          </a:xfrm>
+          <a:prstGeom prst="rect">
+            <a:avLst/>
+          </a:prstGeom>
+          <a:noFill/>
+        </p:spPr>
+        <p:txBody>
+          <a:bodyPr wrap="square" rtlCol="0">
+            <a:spAutoFit/>
+          </a:bodyPr>
+          <a:lstStyle/>
+          <a:p>
+            <a:pPr algn="ctr"/>
+            <a:r>
+              <a:rPr lang="fr-FR" dirty="0"/>
+              <a:t>Résultat sur DE10-Lite</a:t>
+            </a:r>
+          </a:p>
+        </p:txBody>
+      </p:sp>
+      <p:sp>
+        <p:nvSpPr>
+          <p:cNvPr id="15" name="ZoneTexte 14">
+            <a:extLst>
+              <a:ext uri="{FF2B5EF4-FFF2-40B4-BE49-F238E27FC236}">
+                <a16:creationId xmlns:a16="http://schemas.microsoft.com/office/drawing/2014/main" id="{5BFD3DBB-0E77-1538-FF4C-6B91B398C7EB}"/>
+              </a:ext>
+            </a:extLst>
+          </p:cNvPr>
+          <p:cNvSpPr txBox="1"/>
+          <p:nvPr/>
+        </p:nvSpPr>
+        <p:spPr>
+          <a:xfrm>
+            <a:off x="1274643" y="2121961"/>
+            <a:ext cx="4183811" cy="369332"/>
+          </a:xfrm>
+          <a:prstGeom prst="rect">
+            <a:avLst/>
+          </a:prstGeom>
+          <a:noFill/>
+        </p:spPr>
+        <p:txBody>
+          <a:bodyPr wrap="square" rtlCol="0">
+            <a:spAutoFit/>
+          </a:bodyPr>
+          <a:lstStyle/>
+          <a:p>
+            <a:pPr algn="ctr"/>
+            <a:r>
+              <a:rPr lang="fr-FR" dirty="0"/>
+              <a:t>Résultat sur simulation</a:t>
+            </a:r>
+          </a:p>
+        </p:txBody>
+      </p:sp>
+      <p:pic>
+        <p:nvPicPr>
+          <p:cNvPr id="3" name="Image 2">
+            <a:extLst>
+              <a:ext uri="{FF2B5EF4-FFF2-40B4-BE49-F238E27FC236}">
+                <a16:creationId xmlns:a16="http://schemas.microsoft.com/office/drawing/2014/main" id="{46C7C846-A80A-18FE-B32B-49DB97570101}"/>
+              </a:ext>
+            </a:extLst>
+          </p:cNvPr>
+          <p:cNvPicPr>
+            <a:picLocks noChangeAspect="1"/>
+          </p:cNvPicPr>
+          <p:nvPr/>
+        </p:nvPicPr>
+        <p:blipFill>
+          <a:blip r:embed="rId2"/>
+          <a:stretch>
+            <a:fillRect/>
+          </a:stretch>
+        </p:blipFill>
+        <p:spPr>
+          <a:xfrm>
+            <a:off x="1358762" y="1820174"/>
+            <a:ext cx="4015572" cy="234412"/>
+          </a:xfrm>
+          <a:prstGeom prst="rect">
+            <a:avLst/>
+          </a:prstGeom>
+        </p:spPr>
+      </p:pic>
+      <p:pic>
+        <p:nvPicPr>
+          <p:cNvPr id="6" name="Image 5">
+            <a:extLst>
+              <a:ext uri="{FF2B5EF4-FFF2-40B4-BE49-F238E27FC236}">
+                <a16:creationId xmlns:a16="http://schemas.microsoft.com/office/drawing/2014/main" id="{DBE0DCA0-C88D-8487-A896-DA09C8DA7C4E}"/>
+              </a:ext>
+            </a:extLst>
+          </p:cNvPr>
+          <p:cNvPicPr>
+            <a:picLocks noChangeAspect="1"/>
+          </p:cNvPicPr>
+          <p:nvPr/>
+        </p:nvPicPr>
+        <p:blipFill>
+          <a:blip r:embed="rId3"/>
+          <a:stretch>
+            <a:fillRect/>
+          </a:stretch>
+        </p:blipFill>
+        <p:spPr>
+          <a:xfrm>
+            <a:off x="5855407" y="2054586"/>
+            <a:ext cx="6115904" cy="2600688"/>
+          </a:xfrm>
+          <a:prstGeom prst="roundRect">
+            <a:avLst>
+              <a:gd name="adj" fmla="val 13018"/>
+            </a:avLst>
+          </a:prstGeom>
+        </p:spPr>
+      </p:pic>
+      <p:pic>
+        <p:nvPicPr>
+          <p:cNvPr id="8" name="Image 7">
+            <a:extLst>
+              <a:ext uri="{FF2B5EF4-FFF2-40B4-BE49-F238E27FC236}">
+                <a16:creationId xmlns:a16="http://schemas.microsoft.com/office/drawing/2014/main" id="{50488819-2393-2E53-17D8-10EE95AE81F5}"/>
+              </a:ext>
+            </a:extLst>
+          </p:cNvPr>
+          <p:cNvPicPr>
+            <a:picLocks noChangeAspect="1"/>
+          </p:cNvPicPr>
+          <p:nvPr/>
+        </p:nvPicPr>
+        <p:blipFill>
+          <a:blip r:embed="rId4"/>
+          <a:stretch>
+            <a:fillRect/>
+          </a:stretch>
+        </p:blipFill>
+        <p:spPr>
+          <a:xfrm>
+            <a:off x="1743812" y="2626044"/>
+            <a:ext cx="3245471" cy="2674189"/>
+          </a:xfrm>
+          <a:prstGeom prst="roundRect">
+            <a:avLst/>
+          </a:prstGeom>
+        </p:spPr>
+      </p:pic>
+    </p:spTree>
+    <p:extLst>
+      <p:ext uri="{BB962C8B-B14F-4D97-AF65-F5344CB8AC3E}">
+        <p14:creationId xmlns:p14="http://schemas.microsoft.com/office/powerpoint/2010/main" val="2680661445"/>
+      </p:ext>
+    </p:extLst>
+  </p:cSld>
+  <p:clrMapOvr>
+    <a:masterClrMapping/>
+  </p:clrMapOvr>
+</p:sld>
+</file>
+
+<file path=ppt/slides/slide5.xml><?xml version="1.0" encoding="utf-8"?>
+<p:sld xmlns:a="http://schemas.openxmlformats.org/drawingml/2006/main" xmlns:r="http://schemas.openxmlformats.org/officeDocument/2006/relationships" xmlns:p="http://schemas.openxmlformats.org/presentationml/2006/main">
+  <p:cSld>
+    <p:spTree>
+      <p:nvGrpSpPr>
+        <p:cNvPr id="1" name=""/>
+        <p:cNvGrpSpPr/>
+        <p:nvPr/>
+      </p:nvGrpSpPr>
+      <p:grpSpPr>
+        <a:xfrm>
+          <a:off x="0" y="0"/>
+          <a:ext cx="0" cy="0"/>
+          <a:chOff x="0" y="0"/>
+          <a:chExt cx="0" cy="0"/>
+        </a:xfrm>
+      </p:grpSpPr>
+      <p:sp>
+        <p:nvSpPr>
+          <p:cNvPr id="12" name="ZoneTexte 11">
+            <a:extLst>
+              <a:ext uri="{FF2B5EF4-FFF2-40B4-BE49-F238E27FC236}">
+                <a16:creationId xmlns:a16="http://schemas.microsoft.com/office/drawing/2014/main" id="{5DDA3993-169D-6D58-F5BF-4494ACCB4828}"/>
+              </a:ext>
+            </a:extLst>
+          </p:cNvPr>
+          <p:cNvSpPr txBox="1"/>
+          <p:nvPr/>
+        </p:nvSpPr>
+        <p:spPr>
+          <a:xfrm>
+            <a:off x="6821454" y="4787660"/>
+            <a:ext cx="4183811" cy="369332"/>
+          </a:xfrm>
+          <a:prstGeom prst="rect">
+            <a:avLst/>
+          </a:prstGeom>
+          <a:noFill/>
+        </p:spPr>
+        <p:txBody>
+          <a:bodyPr wrap="square" rtlCol="0">
+            <a:spAutoFit/>
+          </a:bodyPr>
+          <a:lstStyle/>
+          <a:p>
+            <a:pPr algn="ctr"/>
+            <a:r>
+              <a:rPr lang="fr-FR" dirty="0"/>
+              <a:t>Donnée de la mémoire</a:t>
+            </a:r>
+          </a:p>
+        </p:txBody>
+      </p:sp>
+      <p:sp>
+        <p:nvSpPr>
+          <p:cNvPr id="13" name="ZoneTexte 12">
+            <a:extLst>
+              <a:ext uri="{FF2B5EF4-FFF2-40B4-BE49-F238E27FC236}">
+                <a16:creationId xmlns:a16="http://schemas.microsoft.com/office/drawing/2014/main" id="{29E05C90-80DD-9DEB-D1C3-81628387349B}"/>
+              </a:ext>
+            </a:extLst>
+          </p:cNvPr>
+          <p:cNvSpPr txBox="1"/>
+          <p:nvPr/>
+        </p:nvSpPr>
+        <p:spPr>
+          <a:xfrm>
+            <a:off x="1274644" y="5300232"/>
+            <a:ext cx="4183811" cy="369332"/>
+          </a:xfrm>
+          <a:prstGeom prst="rect">
+            <a:avLst/>
+          </a:prstGeom>
+          <a:noFill/>
+        </p:spPr>
+        <p:txBody>
+          <a:bodyPr wrap="square" rtlCol="0">
+            <a:spAutoFit/>
+          </a:bodyPr>
+          <a:lstStyle/>
+          <a:p>
+            <a:pPr algn="ctr"/>
+            <a:r>
+              <a:rPr lang="fr-FR" dirty="0"/>
+              <a:t>Résultat sur DE10-Lite</a:t>
+            </a:r>
+          </a:p>
+        </p:txBody>
+      </p:sp>
+      <p:sp>
+        <p:nvSpPr>
+          <p:cNvPr id="15" name="ZoneTexte 14">
+            <a:extLst>
+              <a:ext uri="{FF2B5EF4-FFF2-40B4-BE49-F238E27FC236}">
+                <a16:creationId xmlns:a16="http://schemas.microsoft.com/office/drawing/2014/main" id="{5BFD3DBB-0E77-1538-FF4C-6B91B398C7EB}"/>
+              </a:ext>
+            </a:extLst>
+          </p:cNvPr>
+          <p:cNvSpPr txBox="1"/>
+          <p:nvPr/>
+        </p:nvSpPr>
+        <p:spPr>
+          <a:xfrm>
+            <a:off x="1274643" y="2121961"/>
+            <a:ext cx="4183811" cy="369332"/>
+          </a:xfrm>
+          <a:prstGeom prst="rect">
+            <a:avLst/>
+          </a:prstGeom>
+          <a:noFill/>
+        </p:spPr>
+        <p:txBody>
+          <a:bodyPr wrap="square" rtlCol="0">
+            <a:spAutoFit/>
+          </a:bodyPr>
+          <a:lstStyle/>
+          <a:p>
+            <a:pPr algn="ctr"/>
+            <a:r>
+              <a:rPr lang="fr-FR" dirty="0"/>
+              <a:t>Résultat sur simulation</a:t>
+            </a:r>
+          </a:p>
+        </p:txBody>
+      </p:sp>
+      <p:pic>
+        <p:nvPicPr>
+          <p:cNvPr id="4" name="Image 3">
+            <a:extLst>
+              <a:ext uri="{FF2B5EF4-FFF2-40B4-BE49-F238E27FC236}">
+                <a16:creationId xmlns:a16="http://schemas.microsoft.com/office/drawing/2014/main" id="{92892219-D87C-2D84-59CA-9E6DDC8C951E}"/>
+              </a:ext>
+            </a:extLst>
+          </p:cNvPr>
+          <p:cNvPicPr>
+            <a:picLocks noChangeAspect="1"/>
+          </p:cNvPicPr>
+          <p:nvPr/>
+        </p:nvPicPr>
+        <p:blipFill>
+          <a:blip r:embed="rId2"/>
+          <a:stretch>
+            <a:fillRect/>
+          </a:stretch>
+        </p:blipFill>
+        <p:spPr>
+          <a:xfrm>
+            <a:off x="6047626" y="2069360"/>
+            <a:ext cx="5731466" cy="2585914"/>
+          </a:xfrm>
+          <a:prstGeom prst="roundRect">
+            <a:avLst>
+              <a:gd name="adj" fmla="val 12274"/>
+            </a:avLst>
+          </a:prstGeom>
+        </p:spPr>
+      </p:pic>
+      <p:pic>
+        <p:nvPicPr>
+          <p:cNvPr id="7" name="Image 6">
+            <a:extLst>
+              <a:ext uri="{FF2B5EF4-FFF2-40B4-BE49-F238E27FC236}">
+                <a16:creationId xmlns:a16="http://schemas.microsoft.com/office/drawing/2014/main" id="{137E9F0A-E022-73DD-1E01-56C1E8FABF43}"/>
+              </a:ext>
+            </a:extLst>
+          </p:cNvPr>
+          <p:cNvPicPr>
+            <a:picLocks noChangeAspect="1"/>
+          </p:cNvPicPr>
+          <p:nvPr/>
+        </p:nvPicPr>
+        <p:blipFill>
+          <a:blip r:embed="rId3"/>
+          <a:stretch>
+            <a:fillRect/>
+          </a:stretch>
+        </p:blipFill>
+        <p:spPr>
+          <a:xfrm>
+            <a:off x="1523202" y="1821675"/>
+            <a:ext cx="3686689" cy="247685"/>
+          </a:xfrm>
+          <a:prstGeom prst="rect">
+            <a:avLst/>
+          </a:prstGeom>
+        </p:spPr>
+      </p:pic>
+      <p:pic>
+        <p:nvPicPr>
+          <p:cNvPr id="10" name="Image 9">
+            <a:extLst>
+              <a:ext uri="{FF2B5EF4-FFF2-40B4-BE49-F238E27FC236}">
+                <a16:creationId xmlns:a16="http://schemas.microsoft.com/office/drawing/2014/main" id="{54E79792-345B-D831-2E93-28F973144B1E}"/>
+              </a:ext>
+            </a:extLst>
+          </p:cNvPr>
+          <p:cNvPicPr>
+            <a:picLocks noChangeAspect="1"/>
+          </p:cNvPicPr>
+          <p:nvPr/>
+        </p:nvPicPr>
+        <p:blipFill>
+          <a:blip r:embed="rId4"/>
+          <a:stretch>
+            <a:fillRect/>
+          </a:stretch>
+        </p:blipFill>
+        <p:spPr>
+          <a:xfrm>
+            <a:off x="1547053" y="2544786"/>
+            <a:ext cx="3638986" cy="2755446"/>
+          </a:xfrm>
+          <a:prstGeom prst="roundRect">
+            <a:avLst/>
+          </a:prstGeom>
+        </p:spPr>
+      </p:pic>
+    </p:spTree>
+    <p:extLst>
+      <p:ext uri="{BB962C8B-B14F-4D97-AF65-F5344CB8AC3E}">
+        <p14:creationId xmlns:p14="http://schemas.microsoft.com/office/powerpoint/2010/main" val="2354325544"/>
+      </p:ext>
+    </p:extLst>
+  </p:cSld>
+  <p:clrMapOvr>
+    <a:masterClrMapping/>
+  </p:clrMapOvr>
+</p:sld>
+</file>
+
 <file path=ppt/theme/theme1.xml><?xml version="1.0" encoding="utf-8"?>
 <a:theme xmlns:a="http://schemas.openxmlformats.org/drawingml/2006/main" name="Thème Office">
   <a:themeElements>

</xml_diff>